<commit_message>
Segmentation deck: coloured backgrounds in the minimal design
Title and closing slides on solid teal with two soft circles and white
text; content slides on a soft teal-grey background with white cards and
white tables; charts with a clear chart area.

Co-Authored-By: Claude Opus 5.5 <noreply@anthropic.com>
Claude-Session: https://claude.ai/code/session_01WToQxHdrdWhM7bKqXvUa59
</commit_message>
<xml_diff>
--- a/segmentation/Market_Segmentation.pptx
+++ b/segmentation/Market_Segmentation.pptx
@@ -141,7 +141,7 @@
           </c:tx>
           <c:spPr>
             <a:solidFill>
-              <a:srgbClr val="C5CCD3"/>
+              <a:srgbClr val="B7C1CA"/>
             </a:solidFill>
           </c:spPr>
           <c:dPt>
@@ -283,6 +283,12 @@
     </c:plotArea>
     <c:dispBlanksAs val="gap"/>
   </c:chart>
+  <c:spPr>
+    <a:noFill/>
+    <a:ln>
+      <a:noFill/>
+    </a:ln>
+  </c:spPr>
   <c:txPr>
     <a:bodyPr/>
     <a:lstStyle/>
@@ -330,7 +336,7 @@
           </c:tx>
           <c:spPr>
             <a:solidFill>
-              <a:srgbClr val="C5CCD3"/>
+              <a:srgbClr val="B7C1CA"/>
             </a:solidFill>
           </c:spPr>
           <c:dPt>
@@ -472,6 +478,12 @@
     </c:plotArea>
     <c:dispBlanksAs val="gap"/>
   </c:chart>
+  <c:spPr>
+    <a:noFill/>
+    <a:ln>
+      <a:noFill/>
+    </a:ln>
+  </c:spPr>
   <c:txPr>
     <a:bodyPr/>
     <a:lstStyle/>
@@ -4320,6 +4332,14 @@
 <file path=ppt/slides/slide1.xml><?xml version="1.0" encoding="utf-8"?>
 <p:sld xmlns:a="http://schemas.openxmlformats.org/drawingml/2006/main" xmlns:p="http://schemas.openxmlformats.org/presentationml/2006/main" xmlns:r="http://schemas.openxmlformats.org/officeDocument/2006/relationships">
   <p:cSld>
+    <p:bg>
+      <p:bgPr>
+        <a:solidFill>
+          <a:srgbClr val="0F766E"/>
+        </a:solidFill>
+        <a:effectLst/>
+      </p:bgPr>
+    </p:bg>
     <p:spTree>
       <p:nvGrpSpPr>
         <p:cNvPr id="1" name=""/>
@@ -4329,106 +4349,20 @@
       <p:grpSpPr/>
       <p:sp>
         <p:nvSpPr>
-          <p:cNvPr id="2" name="Title 1"/>
-          <p:cNvSpPr>
-            <a:spLocks noGrp="1"/>
-          </p:cNvSpPr>
-          <p:nvPr>
-            <p:ph type="ctrTitle"/>
-          </p:nvPr>
+          <p:cNvPr id="4" name="Oval 3"/>
+          <p:cNvSpPr/>
+          <p:nvPr/>
         </p:nvSpPr>
         <p:spPr>
           <a:xfrm>
-            <a:off x="1005840" y="2057400"/>
-            <a:ext cx="10180320" cy="1371600"/>
+            <a:off x="7985760" y="-1645920"/>
+            <a:ext cx="6583680" cy="6583680"/>
           </a:xfrm>
-        </p:spPr>
-        <p:txBody>
-          <a:bodyPr anchor="b"/>
-          <a:lstStyle/>
-          <a:p>
-            <a:pPr algn="l"/>
-            <a:r>
-              <a:rPr sz="5400" b="0">
-                <a:solidFill>
-                  <a:srgbClr val="1F2933"/>
-                </a:solidFill>
-                <a:latin typeface="Calibri Light"/>
-              </a:rPr>
-              <a:t>Market Segmentation</a:t>
-            </a:r>
-          </a:p>
-        </p:txBody>
-      </p:sp>
-      <p:sp>
-        <p:nvSpPr>
-          <p:cNvPr id="3" name="Subtitle 2"/>
-          <p:cNvSpPr>
-            <a:spLocks noGrp="1"/>
-          </p:cNvSpPr>
-          <p:nvPr>
-            <p:ph type="subTitle" idx="1"/>
-          </p:nvPr>
-        </p:nvSpPr>
-        <p:spPr>
-          <a:xfrm>
-            <a:off x="1005840" y="3840480"/>
-            <a:ext cx="10180320" cy="1828800"/>
-          </a:xfrm>
-        </p:spPr>
-        <p:txBody>
-          <a:bodyPr anchor="t"/>
-          <a:lstStyle/>
-          <a:p>
-            <a:pPr algn="l">
-              <a:spcAft>
-                <a:spcPts val="800"/>
-              </a:spcAft>
-            </a:pPr>
-            <a:r>
-              <a:rPr sz="2400" b="0">
-                <a:solidFill>
-                  <a:srgbClr val="616E7C"/>
-                </a:solidFill>
-                <a:latin typeface="Calibri"/>
-              </a:rPr>
-              <a:t>SkillUp Academy: a new digital-skills training business</a:t>
-            </a:r>
-          </a:p>
-          <a:p>
-            <a:pPr algn="l">
-              <a:spcAft>
-                <a:spcPts val="800"/>
-              </a:spcAft>
-            </a:pPr>
-            <a:r>
-              <a:rPr sz="1600" b="0">
-                <a:solidFill>
-                  <a:srgbClr val="616E7C"/>
-                </a:solidFill>
-                <a:latin typeface="Calibri"/>
-              </a:rPr>
-              <a:t>Market Research Lab  ·  Google Trends, Nigeria, past 12 months</a:t>
-            </a:r>
-          </a:p>
-        </p:txBody>
-      </p:sp>
-      <p:sp>
-        <p:nvSpPr>
-          <p:cNvPr id="4" name="Rectangle 3"/>
-          <p:cNvSpPr/>
-          <p:nvPr/>
-        </p:nvSpPr>
-        <p:spPr>
-          <a:xfrm>
-            <a:off x="0" y="0"/>
-            <a:ext cx="256032" cy="6858000"/>
-          </a:xfrm>
-          <a:prstGeom prst="rect">
+          <a:prstGeom prst="ellipse">
             <a:avLst/>
           </a:prstGeom>
           <a:solidFill>
-            <a:srgbClr val="0F766E"/>
+            <a:srgbClr val="13827A"/>
           </a:solidFill>
           <a:ln>
             <a:noFill/>
@@ -4456,9 +4390,138 @@
           </a:p>
         </p:txBody>
       </p:sp>
+      <p:sp>
+        <p:nvSpPr>
+          <p:cNvPr id="5" name="Oval 4"/>
+          <p:cNvSpPr/>
+          <p:nvPr/>
+        </p:nvSpPr>
+        <p:spPr>
+          <a:xfrm>
+            <a:off x="9448800" y="3840480"/>
+            <a:ext cx="4114800" cy="4114800"/>
+          </a:xfrm>
+          <a:prstGeom prst="ellipse">
+            <a:avLst/>
+          </a:prstGeom>
+          <a:noFill/>
+          <a:ln w="15875">
+            <a:solidFill>
+              <a:srgbClr val="8ED1C7"/>
+            </a:solidFill>
+          </a:ln>
+        </p:spPr>
+        <p:style>
+          <a:lnRef idx="1">
+            <a:schemeClr val="accent1"/>
+          </a:lnRef>
+          <a:fillRef idx="3">
+            <a:schemeClr val="accent1"/>
+          </a:fillRef>
+          <a:effectRef idx="2">
+            <a:schemeClr val="accent1"/>
+          </a:effectRef>
+          <a:fontRef idx="minor">
+            <a:schemeClr val="lt1"/>
+          </a:fontRef>
+        </p:style>
+        <p:txBody>
+          <a:bodyPr rtlCol="0" anchor="ctr"/>
+          <a:lstStyle/>
+          <a:p>
+            <a:pPr algn="ctr"/>
+          </a:p>
+        </p:txBody>
+      </p:sp>
+      <p:sp>
+        <p:nvSpPr>
+          <p:cNvPr id="2" name="Title 1"/>
+          <p:cNvSpPr>
+            <a:spLocks noGrp="1"/>
+          </p:cNvSpPr>
+          <p:nvPr>
+            <p:ph type="ctrTitle"/>
+          </p:nvPr>
+        </p:nvSpPr>
+        <p:spPr>
+          <a:xfrm>
+            <a:off x="1005840" y="2057400"/>
+            <a:ext cx="10180320" cy="1371600"/>
+          </a:xfrm>
+        </p:spPr>
+        <p:txBody>
+          <a:bodyPr anchor="b"/>
+          <a:lstStyle/>
+          <a:p>
+            <a:pPr algn="l"/>
+            <a:r>
+              <a:rPr sz="5400" b="0">
+                <a:solidFill>
+                  <a:srgbClr val="FFFFFF"/>
+                </a:solidFill>
+                <a:latin typeface="Calibri Light"/>
+              </a:rPr>
+              <a:t>Market Segmentation</a:t>
+            </a:r>
+          </a:p>
+        </p:txBody>
+      </p:sp>
+      <p:sp>
+        <p:nvSpPr>
+          <p:cNvPr id="3" name="Subtitle 2"/>
+          <p:cNvSpPr>
+            <a:spLocks noGrp="1"/>
+          </p:cNvSpPr>
+          <p:nvPr>
+            <p:ph type="subTitle" idx="1"/>
+          </p:nvPr>
+        </p:nvSpPr>
+        <p:spPr>
+          <a:xfrm>
+            <a:off x="1005840" y="3840480"/>
+            <a:ext cx="10180320" cy="1828800"/>
+          </a:xfrm>
+        </p:spPr>
+        <p:txBody>
+          <a:bodyPr anchor="t"/>
+          <a:lstStyle/>
+          <a:p>
+            <a:pPr algn="l">
+              <a:spcAft>
+                <a:spcPts val="800"/>
+              </a:spcAft>
+            </a:pPr>
+            <a:r>
+              <a:rPr sz="2400" b="0">
+                <a:solidFill>
+                  <a:srgbClr val="D3EBE7"/>
+                </a:solidFill>
+                <a:latin typeface="Calibri"/>
+              </a:rPr>
+              <a:t>SkillUp Academy: a new digital-skills training business</a:t>
+            </a:r>
+          </a:p>
+          <a:p>
+            <a:pPr algn="l">
+              <a:spcAft>
+                <a:spcPts val="800"/>
+              </a:spcAft>
+            </a:pPr>
+            <a:r>
+              <a:rPr sz="1600" b="0">
+                <a:solidFill>
+                  <a:srgbClr val="D3EBE7"/>
+                </a:solidFill>
+                <a:latin typeface="Calibri"/>
+              </a:rPr>
+              <a:t>Market Research Lab  ·  Google Trends, Nigeria, past 12 months</a:t>
+            </a:r>
+          </a:p>
+        </p:txBody>
+      </p:sp>
       <p:cxnSp>
         <p:nvCxnSpPr>
-          <p:cNvPr id="5" name="Straight Connector 4"/>
+          <p:cNvPr id="6" name="Straight Connector 5"/>
           <p:cNvCxnSpPr/>
           <p:nvPr/>
         </p:nvCxnSpPr>
@@ -4472,7 +4535,7 @@
           </a:prstGeom>
           <a:ln w="38100">
             <a:solidFill>
-              <a:srgbClr val="0F766E"/>
+              <a:srgbClr val="8ED1C7"/>
             </a:solidFill>
           </a:ln>
         </p:spPr>
@@ -4580,7 +4643,7 @@
                                           </p:stCondLst>
                                         </p:cTn>
                                         <p:tgtEl>
-                                          <p:spTgt spid="5"/>
+                                          <p:spTgt spid="6"/>
                                         </p:tgtEl>
                                         <p:attrNameLst>
                                           <p:attrName>style.visibility</p:attrName>
@@ -4594,7 +4657,7 @@
                                       <p:cBhvr>
                                         <p:cTn id="11" dur="500"/>
                                         <p:tgtEl>
-                                          <p:spTgt spid="5"/>
+                                          <p:spTgt spid="6"/>
                                         </p:tgtEl>
                                       </p:cBhvr>
                                     </p:animEffect>
@@ -4683,6 +4746,14 @@
 <file path=ppt/slides/slide2.xml><?xml version="1.0" encoding="utf-8"?>
 <p:sld xmlns:a="http://schemas.openxmlformats.org/drawingml/2006/main" xmlns:p="http://schemas.openxmlformats.org/presentationml/2006/main" xmlns:r="http://schemas.openxmlformats.org/officeDocument/2006/relationships">
   <p:cSld>
+    <p:bg>
+      <p:bgPr>
+        <a:solidFill>
+          <a:srgbClr val="E4EFEC"/>
+        </a:solidFill>
+        <a:effectLst/>
+      </p:bgPr>
+    </p:bg>
     <p:spTree>
       <p:nvGrpSpPr>
         <p:cNvPr id="1" name=""/>
@@ -4738,7 +4809,7 @@
             <a:avLst/>
           </a:prstGeom>
           <a:solidFill>
-            <a:srgbClr val="F2F5F5"/>
+            <a:srgbClr val="FFFFFF"/>
           </a:solidFill>
           <a:ln>
             <a:noFill/>
@@ -4994,7 +5065,7 @@
             <a:r>
               <a:rPr sz="1600" b="0">
                 <a:solidFill>
-                  <a:srgbClr val="616E7C"/>
+                  <a:srgbClr val="55606E"/>
                 </a:solidFill>
                 <a:latin typeface="Calibri"/>
               </a:rPr>
@@ -5028,7 +5099,7 @@
             <a:r>
               <a:rPr sz="1000" b="0">
                 <a:solidFill>
-                  <a:srgbClr val="616E7C"/>
+                  <a:srgbClr val="55606E"/>
                 </a:solidFill>
                 <a:latin typeface="Calibri"/>
               </a:rPr>
@@ -5063,7 +5134,7 @@
             <a:r>
               <a:rPr sz="1000" b="0">
                 <a:solidFill>
-                  <a:srgbClr val="616E7C"/>
+                  <a:srgbClr val="55606E"/>
                 </a:solidFill>
                 <a:latin typeface="Calibri"/>
               </a:rPr>
@@ -5372,6 +5443,14 @@
 <file path=ppt/slides/slide3.xml><?xml version="1.0" encoding="utf-8"?>
 <p:sld xmlns:a="http://schemas.openxmlformats.org/drawingml/2006/main" xmlns:p="http://schemas.openxmlformats.org/presentationml/2006/main" xmlns:r="http://schemas.openxmlformats.org/officeDocument/2006/relationships">
   <p:cSld>
+    <p:bg>
+      <p:bgPr>
+        <a:solidFill>
+          <a:srgbClr val="E4EFEC"/>
+        </a:solidFill>
+        <a:effectLst/>
+      </p:bgPr>
+    </p:bg>
     <p:spTree>
       <p:nvGrpSpPr>
         <p:cNvPr id="1" name=""/>
@@ -5475,7 +5554,9 @@
                       <a:headEnd type="none" w="med" len="med"/>
                       <a:tailEnd type="none" w="med" len="med"/>
                     </a:lnB>
-                    <a:noFill/>
+                    <a:solidFill>
+                      <a:srgbClr val="FFFFFF"/>
+                    </a:solidFill>
                   </a:tcPr>
                 </a:tc>
                 <a:tc>
@@ -5514,7 +5595,9 @@
                       <a:headEnd type="none" w="med" len="med"/>
                       <a:tailEnd type="none" w="med" len="med"/>
                     </a:lnB>
-                    <a:noFill/>
+                    <a:solidFill>
+                      <a:srgbClr val="FFFFFF"/>
+                    </a:solidFill>
                   </a:tcPr>
                 </a:tc>
                 <a:tc>
@@ -5553,7 +5636,9 @@
                       <a:headEnd type="none" w="med" len="med"/>
                       <a:tailEnd type="none" w="med" len="med"/>
                     </a:lnB>
-                    <a:noFill/>
+                    <a:solidFill>
+                      <a:srgbClr val="FFFFFF"/>
+                    </a:solidFill>
                   </a:tcPr>
                 </a:tc>
                 <a:tc>
@@ -5592,7 +5677,9 @@
                       <a:headEnd type="none" w="med" len="med"/>
                       <a:tailEnd type="none" w="med" len="med"/>
                     </a:lnB>
-                    <a:noFill/>
+                    <a:solidFill>
+                      <a:srgbClr val="FFFFFF"/>
+                    </a:solidFill>
                   </a:tcPr>
                 </a:tc>
               </a:tr>
@@ -5639,7 +5726,9 @@
                       <a:headEnd type="none" w="med" len="med"/>
                       <a:tailEnd type="none" w="med" len="med"/>
                     </a:lnB>
-                    <a:noFill/>
+                    <a:solidFill>
+                      <a:srgbClr val="FFFFFF"/>
+                    </a:solidFill>
                   </a:tcPr>
                 </a:tc>
                 <a:tc>
@@ -5684,7 +5773,9 @@
                       <a:headEnd type="none" w="med" len="med"/>
                       <a:tailEnd type="none" w="med" len="med"/>
                     </a:lnB>
-                    <a:noFill/>
+                    <a:solidFill>
+                      <a:srgbClr val="FFFFFF"/>
+                    </a:solidFill>
                   </a:tcPr>
                 </a:tc>
                 <a:tc>
@@ -5729,7 +5820,9 @@
                       <a:headEnd type="none" w="med" len="med"/>
                       <a:tailEnd type="none" w="med" len="med"/>
                     </a:lnB>
-                    <a:noFill/>
+                    <a:solidFill>
+                      <a:srgbClr val="FFFFFF"/>
+                    </a:solidFill>
                   </a:tcPr>
                 </a:tc>
                 <a:tc>
@@ -5774,7 +5867,9 @@
                       <a:headEnd type="none" w="med" len="med"/>
                       <a:tailEnd type="none" w="med" len="med"/>
                     </a:lnB>
-                    <a:noFill/>
+                    <a:solidFill>
+                      <a:srgbClr val="FFFFFF"/>
+                    </a:solidFill>
                   </a:tcPr>
                 </a:tc>
               </a:tr>
@@ -5821,7 +5916,9 @@
                       <a:headEnd type="none" w="med" len="med"/>
                       <a:tailEnd type="none" w="med" len="med"/>
                     </a:lnB>
-                    <a:noFill/>
+                    <a:solidFill>
+                      <a:srgbClr val="FFFFFF"/>
+                    </a:solidFill>
                   </a:tcPr>
                 </a:tc>
                 <a:tc>
@@ -5866,7 +5963,9 @@
                       <a:headEnd type="none" w="med" len="med"/>
                       <a:tailEnd type="none" w="med" len="med"/>
                     </a:lnB>
-                    <a:noFill/>
+                    <a:solidFill>
+                      <a:srgbClr val="FFFFFF"/>
+                    </a:solidFill>
                   </a:tcPr>
                 </a:tc>
                 <a:tc>
@@ -5911,7 +6010,9 @@
                       <a:headEnd type="none" w="med" len="med"/>
                       <a:tailEnd type="none" w="med" len="med"/>
                     </a:lnB>
-                    <a:noFill/>
+                    <a:solidFill>
+                      <a:srgbClr val="FFFFFF"/>
+                    </a:solidFill>
                   </a:tcPr>
                 </a:tc>
                 <a:tc>
@@ -5956,7 +6057,9 @@
                       <a:headEnd type="none" w="med" len="med"/>
                       <a:tailEnd type="none" w="med" len="med"/>
                     </a:lnB>
-                    <a:noFill/>
+                    <a:solidFill>
+                      <a:srgbClr val="FFFFFF"/>
+                    </a:solidFill>
                   </a:tcPr>
                 </a:tc>
               </a:tr>
@@ -6003,7 +6106,9 @@
                       <a:headEnd type="none" w="med" len="med"/>
                       <a:tailEnd type="none" w="med" len="med"/>
                     </a:lnB>
-                    <a:noFill/>
+                    <a:solidFill>
+                      <a:srgbClr val="FFFFFF"/>
+                    </a:solidFill>
                   </a:tcPr>
                 </a:tc>
                 <a:tc>
@@ -6048,7 +6153,9 @@
                       <a:headEnd type="none" w="med" len="med"/>
                       <a:tailEnd type="none" w="med" len="med"/>
                     </a:lnB>
-                    <a:noFill/>
+                    <a:solidFill>
+                      <a:srgbClr val="FFFFFF"/>
+                    </a:solidFill>
                   </a:tcPr>
                 </a:tc>
                 <a:tc>
@@ -6093,7 +6200,9 @@
                       <a:headEnd type="none" w="med" len="med"/>
                       <a:tailEnd type="none" w="med" len="med"/>
                     </a:lnB>
-                    <a:noFill/>
+                    <a:solidFill>
+                      <a:srgbClr val="FFFFFF"/>
+                    </a:solidFill>
                   </a:tcPr>
                 </a:tc>
                 <a:tc>
@@ -6138,7 +6247,9 @@
                       <a:headEnd type="none" w="med" len="med"/>
                       <a:tailEnd type="none" w="med" len="med"/>
                     </a:lnB>
-                    <a:noFill/>
+                    <a:solidFill>
+                      <a:srgbClr val="FFFFFF"/>
+                    </a:solidFill>
                   </a:tcPr>
                 </a:tc>
               </a:tr>
@@ -6185,7 +6296,9 @@
                       <a:headEnd type="none" w="med" len="med"/>
                       <a:tailEnd type="none" w="med" len="med"/>
                     </a:lnB>
-                    <a:noFill/>
+                    <a:solidFill>
+                      <a:srgbClr val="FFFFFF"/>
+                    </a:solidFill>
                   </a:tcPr>
                 </a:tc>
                 <a:tc>
@@ -6230,7 +6343,9 @@
                       <a:headEnd type="none" w="med" len="med"/>
                       <a:tailEnd type="none" w="med" len="med"/>
                     </a:lnB>
-                    <a:noFill/>
+                    <a:solidFill>
+                      <a:srgbClr val="FFFFFF"/>
+                    </a:solidFill>
                   </a:tcPr>
                 </a:tc>
                 <a:tc>
@@ -6275,7 +6390,9 @@
                       <a:headEnd type="none" w="med" len="med"/>
                       <a:tailEnd type="none" w="med" len="med"/>
                     </a:lnB>
-                    <a:noFill/>
+                    <a:solidFill>
+                      <a:srgbClr val="FFFFFF"/>
+                    </a:solidFill>
                   </a:tcPr>
                 </a:tc>
                 <a:tc>
@@ -6320,7 +6437,9 @@
                       <a:headEnd type="none" w="med" len="med"/>
                       <a:tailEnd type="none" w="med" len="med"/>
                     </a:lnB>
-                    <a:noFill/>
+                    <a:solidFill>
+                      <a:srgbClr val="FFFFFF"/>
+                    </a:solidFill>
                   </a:tcPr>
                 </a:tc>
               </a:tr>
@@ -6367,7 +6486,9 @@
                       <a:headEnd type="none" w="med" len="med"/>
                       <a:tailEnd type="none" w="med" len="med"/>
                     </a:lnB>
-                    <a:noFill/>
+                    <a:solidFill>
+                      <a:srgbClr val="FFFFFF"/>
+                    </a:solidFill>
                   </a:tcPr>
                 </a:tc>
                 <a:tc>
@@ -6412,7 +6533,9 @@
                       <a:headEnd type="none" w="med" len="med"/>
                       <a:tailEnd type="none" w="med" len="med"/>
                     </a:lnB>
-                    <a:noFill/>
+                    <a:solidFill>
+                      <a:srgbClr val="FFFFFF"/>
+                    </a:solidFill>
                   </a:tcPr>
                 </a:tc>
                 <a:tc>
@@ -6457,7 +6580,9 @@
                       <a:headEnd type="none" w="med" len="med"/>
                       <a:tailEnd type="none" w="med" len="med"/>
                     </a:lnB>
-                    <a:noFill/>
+                    <a:solidFill>
+                      <a:srgbClr val="FFFFFF"/>
+                    </a:solidFill>
                   </a:tcPr>
                 </a:tc>
                 <a:tc>
@@ -6502,7 +6627,9 @@
                       <a:headEnd type="none" w="med" len="med"/>
                       <a:tailEnd type="none" w="med" len="med"/>
                     </a:lnB>
-                    <a:noFill/>
+                    <a:solidFill>
+                      <a:srgbClr val="FFFFFF"/>
+                    </a:solidFill>
                   </a:tcPr>
                 </a:tc>
               </a:tr>
@@ -6571,7 +6698,7 @@
             <a:r>
               <a:rPr sz="1600" b="0">
                 <a:solidFill>
-                  <a:srgbClr val="616E7C"/>
+                  <a:srgbClr val="55606E"/>
                 </a:solidFill>
                 <a:latin typeface="Calibri"/>
               </a:rPr>
@@ -6605,7 +6732,7 @@
             <a:r>
               <a:rPr sz="1000" b="0">
                 <a:solidFill>
-                  <a:srgbClr val="616E7C"/>
+                  <a:srgbClr val="55606E"/>
                 </a:solidFill>
                 <a:latin typeface="Calibri"/>
               </a:rPr>
@@ -6640,7 +6767,7 @@
             <a:r>
               <a:rPr sz="1000" b="0">
                 <a:solidFill>
-                  <a:srgbClr val="616E7C"/>
+                  <a:srgbClr val="55606E"/>
                 </a:solidFill>
                 <a:latin typeface="Calibri"/>
               </a:rPr>
@@ -6674,7 +6801,7 @@
             <a:r>
               <a:rPr sz="1400" b="0">
                 <a:solidFill>
-                  <a:srgbClr val="616E7C"/>
+                  <a:srgbClr val="55606E"/>
                 </a:solidFill>
                 <a:latin typeface="Calibri"/>
               </a:rPr>
@@ -6955,6 +7082,14 @@
 <file path=ppt/slides/slide4.xml><?xml version="1.0" encoding="utf-8"?>
 <p:sld xmlns:a="http://schemas.openxmlformats.org/drawingml/2006/main" xmlns:p="http://schemas.openxmlformats.org/presentationml/2006/main" xmlns:r="http://schemas.openxmlformats.org/officeDocument/2006/relationships">
   <p:cSld>
+    <p:bg>
+      <p:bgPr>
+        <a:solidFill>
+          <a:srgbClr val="E4EFEC"/>
+        </a:solidFill>
+        <a:effectLst/>
+      </p:bgPr>
+    </p:bg>
     <p:spTree>
       <p:nvGrpSpPr>
         <p:cNvPr id="1" name=""/>
@@ -7076,7 +7211,7 @@
             <a:r>
               <a:rPr sz="1600" b="0">
                 <a:solidFill>
-                  <a:srgbClr val="616E7C"/>
+                  <a:srgbClr val="55606E"/>
                 </a:solidFill>
                 <a:latin typeface="Calibri"/>
               </a:rPr>
@@ -7110,7 +7245,7 @@
             <a:r>
               <a:rPr sz="1000" b="0">
                 <a:solidFill>
-                  <a:srgbClr val="616E7C"/>
+                  <a:srgbClr val="55606E"/>
                 </a:solidFill>
                 <a:latin typeface="Calibri"/>
               </a:rPr>
@@ -7145,7 +7280,7 @@
             <a:r>
               <a:rPr sz="1000" b="0">
                 <a:solidFill>
-                  <a:srgbClr val="616E7C"/>
+                  <a:srgbClr val="55606E"/>
                 </a:solidFill>
                 <a:latin typeface="Calibri"/>
               </a:rPr>
@@ -7169,7 +7304,7 @@
             <a:avLst/>
           </a:prstGeom>
           <a:solidFill>
-            <a:srgbClr val="F2F5F5"/>
+            <a:srgbClr val="FFFFFF"/>
           </a:solidFill>
           <a:ln>
             <a:noFill/>
@@ -7685,6 +7820,14 @@
 <file path=ppt/slides/slide5.xml><?xml version="1.0" encoding="utf-8"?>
 <p:sld xmlns:a="http://schemas.openxmlformats.org/drawingml/2006/main" xmlns:p="http://schemas.openxmlformats.org/presentationml/2006/main" xmlns:r="http://schemas.openxmlformats.org/officeDocument/2006/relationships">
   <p:cSld>
+    <p:bg>
+      <p:bgPr>
+        <a:solidFill>
+          <a:srgbClr val="E4EFEC"/>
+        </a:solidFill>
+        <a:effectLst/>
+      </p:bgPr>
+    </p:bg>
     <p:spTree>
       <p:nvGrpSpPr>
         <p:cNvPr id="1" name=""/>
@@ -7787,7 +7930,9 @@
                       <a:headEnd type="none" w="med" len="med"/>
                       <a:tailEnd type="none" w="med" len="med"/>
                     </a:lnB>
-                    <a:noFill/>
+                    <a:solidFill>
+                      <a:srgbClr val="FFFFFF"/>
+                    </a:solidFill>
                   </a:tcPr>
                 </a:tc>
                 <a:tc>
@@ -7826,7 +7971,9 @@
                       <a:headEnd type="none" w="med" len="med"/>
                       <a:tailEnd type="none" w="med" len="med"/>
                     </a:lnB>
-                    <a:noFill/>
+                    <a:solidFill>
+                      <a:srgbClr val="FFFFFF"/>
+                    </a:solidFill>
                   </a:tcPr>
                 </a:tc>
                 <a:tc>
@@ -7865,7 +8012,9 @@
                       <a:headEnd type="none" w="med" len="med"/>
                       <a:tailEnd type="none" w="med" len="med"/>
                     </a:lnB>
-                    <a:noFill/>
+                    <a:solidFill>
+                      <a:srgbClr val="FFFFFF"/>
+                    </a:solidFill>
                   </a:tcPr>
                 </a:tc>
               </a:tr>
@@ -7912,7 +8061,9 @@
                       <a:headEnd type="none" w="med" len="med"/>
                       <a:tailEnd type="none" w="med" len="med"/>
                     </a:lnB>
-                    <a:noFill/>
+                    <a:solidFill>
+                      <a:srgbClr val="FFFFFF"/>
+                    </a:solidFill>
                   </a:tcPr>
                 </a:tc>
                 <a:tc>
@@ -7957,7 +8108,9 @@
                       <a:headEnd type="none" w="med" len="med"/>
                       <a:tailEnd type="none" w="med" len="med"/>
                     </a:lnB>
-                    <a:noFill/>
+                    <a:solidFill>
+                      <a:srgbClr val="FFFFFF"/>
+                    </a:solidFill>
                   </a:tcPr>
                 </a:tc>
                 <a:tc>
@@ -8002,7 +8155,9 @@
                       <a:headEnd type="none" w="med" len="med"/>
                       <a:tailEnd type="none" w="med" len="med"/>
                     </a:lnB>
-                    <a:noFill/>
+                    <a:solidFill>
+                      <a:srgbClr val="FFFFFF"/>
+                    </a:solidFill>
                   </a:tcPr>
                 </a:tc>
               </a:tr>
@@ -8049,7 +8204,9 @@
                       <a:headEnd type="none" w="med" len="med"/>
                       <a:tailEnd type="none" w="med" len="med"/>
                     </a:lnB>
-                    <a:noFill/>
+                    <a:solidFill>
+                      <a:srgbClr val="FFFFFF"/>
+                    </a:solidFill>
                   </a:tcPr>
                 </a:tc>
                 <a:tc>
@@ -8094,7 +8251,9 @@
                       <a:headEnd type="none" w="med" len="med"/>
                       <a:tailEnd type="none" w="med" len="med"/>
                     </a:lnB>
-                    <a:noFill/>
+                    <a:solidFill>
+                      <a:srgbClr val="FFFFFF"/>
+                    </a:solidFill>
                   </a:tcPr>
                 </a:tc>
                 <a:tc>
@@ -8139,7 +8298,9 @@
                       <a:headEnd type="none" w="med" len="med"/>
                       <a:tailEnd type="none" w="med" len="med"/>
                     </a:lnB>
-                    <a:noFill/>
+                    <a:solidFill>
+                      <a:srgbClr val="FFFFFF"/>
+                    </a:solidFill>
                   </a:tcPr>
                 </a:tc>
               </a:tr>
@@ -8186,7 +8347,9 @@
                       <a:headEnd type="none" w="med" len="med"/>
                       <a:tailEnd type="none" w="med" len="med"/>
                     </a:lnB>
-                    <a:noFill/>
+                    <a:solidFill>
+                      <a:srgbClr val="FFFFFF"/>
+                    </a:solidFill>
                   </a:tcPr>
                 </a:tc>
                 <a:tc>
@@ -8231,7 +8394,9 @@
                       <a:headEnd type="none" w="med" len="med"/>
                       <a:tailEnd type="none" w="med" len="med"/>
                     </a:lnB>
-                    <a:noFill/>
+                    <a:solidFill>
+                      <a:srgbClr val="FFFFFF"/>
+                    </a:solidFill>
                   </a:tcPr>
                 </a:tc>
                 <a:tc>
@@ -8276,7 +8441,9 @@
                       <a:headEnd type="none" w="med" len="med"/>
                       <a:tailEnd type="none" w="med" len="med"/>
                     </a:lnB>
-                    <a:noFill/>
+                    <a:solidFill>
+                      <a:srgbClr val="FFFFFF"/>
+                    </a:solidFill>
                   </a:tcPr>
                 </a:tc>
               </a:tr>
@@ -8323,7 +8490,9 @@
                       <a:headEnd type="none" w="med" len="med"/>
                       <a:tailEnd type="none" w="med" len="med"/>
                     </a:lnB>
-                    <a:noFill/>
+                    <a:solidFill>
+                      <a:srgbClr val="FFFFFF"/>
+                    </a:solidFill>
                   </a:tcPr>
                 </a:tc>
                 <a:tc>
@@ -8368,7 +8537,9 @@
                       <a:headEnd type="none" w="med" len="med"/>
                       <a:tailEnd type="none" w="med" len="med"/>
                     </a:lnB>
-                    <a:noFill/>
+                    <a:solidFill>
+                      <a:srgbClr val="FFFFFF"/>
+                    </a:solidFill>
                   </a:tcPr>
                 </a:tc>
                 <a:tc>
@@ -8413,7 +8584,9 @@
                       <a:headEnd type="none" w="med" len="med"/>
                       <a:tailEnd type="none" w="med" len="med"/>
                     </a:lnB>
-                    <a:noFill/>
+                    <a:solidFill>
+                      <a:srgbClr val="FFFFFF"/>
+                    </a:solidFill>
                   </a:tcPr>
                 </a:tc>
               </a:tr>
@@ -8460,7 +8633,9 @@
                       <a:headEnd type="none" w="med" len="med"/>
                       <a:tailEnd type="none" w="med" len="med"/>
                     </a:lnB>
-                    <a:noFill/>
+                    <a:solidFill>
+                      <a:srgbClr val="FFFFFF"/>
+                    </a:solidFill>
                   </a:tcPr>
                 </a:tc>
                 <a:tc>
@@ -8505,7 +8680,9 @@
                       <a:headEnd type="none" w="med" len="med"/>
                       <a:tailEnd type="none" w="med" len="med"/>
                     </a:lnB>
-                    <a:noFill/>
+                    <a:solidFill>
+                      <a:srgbClr val="FFFFFF"/>
+                    </a:solidFill>
                   </a:tcPr>
                 </a:tc>
                 <a:tc>
@@ -8550,7 +8727,9 @@
                       <a:headEnd type="none" w="med" len="med"/>
                       <a:tailEnd type="none" w="med" len="med"/>
                     </a:lnB>
-                    <a:noFill/>
+                    <a:solidFill>
+                      <a:srgbClr val="FFFFFF"/>
+                    </a:solidFill>
                   </a:tcPr>
                 </a:tc>
               </a:tr>
@@ -8619,7 +8798,7 @@
             <a:r>
               <a:rPr sz="1600" b="0">
                 <a:solidFill>
-                  <a:srgbClr val="616E7C"/>
+                  <a:srgbClr val="55606E"/>
                 </a:solidFill>
                 <a:latin typeface="Calibri"/>
               </a:rPr>
@@ -8653,7 +8832,7 @@
             <a:r>
               <a:rPr sz="1000" b="0">
                 <a:solidFill>
-                  <a:srgbClr val="616E7C"/>
+                  <a:srgbClr val="55606E"/>
                 </a:solidFill>
                 <a:latin typeface="Calibri"/>
               </a:rPr>
@@ -8688,7 +8867,7 @@
             <a:r>
               <a:rPr sz="1000" b="0">
                 <a:solidFill>
-                  <a:srgbClr val="616E7C"/>
+                  <a:srgbClr val="55606E"/>
                 </a:solidFill>
                 <a:latin typeface="Calibri"/>
               </a:rPr>
@@ -8722,7 +8901,7 @@
             <a:r>
               <a:rPr sz="1400" b="0">
                 <a:solidFill>
-                  <a:srgbClr val="616E7C"/>
+                  <a:srgbClr val="55606E"/>
                 </a:solidFill>
                 <a:latin typeface="Calibri"/>
               </a:rPr>
@@ -9003,6 +9182,14 @@
 <file path=ppt/slides/slide6.xml><?xml version="1.0" encoding="utf-8"?>
 <p:sld xmlns:a="http://schemas.openxmlformats.org/drawingml/2006/main" xmlns:p="http://schemas.openxmlformats.org/presentationml/2006/main" xmlns:r="http://schemas.openxmlformats.org/officeDocument/2006/relationships">
   <p:cSld>
+    <p:bg>
+      <p:bgPr>
+        <a:solidFill>
+          <a:srgbClr val="E4EFEC"/>
+        </a:solidFill>
+        <a:effectLst/>
+      </p:bgPr>
+    </p:bg>
     <p:spTree>
       <p:nvGrpSpPr>
         <p:cNvPr id="1" name=""/>
@@ -9109,7 +9296,9 @@
                       <a:headEnd type="none" w="med" len="med"/>
                       <a:tailEnd type="none" w="med" len="med"/>
                     </a:lnB>
-                    <a:noFill/>
+                    <a:solidFill>
+                      <a:srgbClr val="FFFFFF"/>
+                    </a:solidFill>
                   </a:tcPr>
                 </a:tc>
                 <a:tc>
@@ -9148,7 +9337,9 @@
                       <a:headEnd type="none" w="med" len="med"/>
                       <a:tailEnd type="none" w="med" len="med"/>
                     </a:lnB>
-                    <a:noFill/>
+                    <a:solidFill>
+                      <a:srgbClr val="FFFFFF"/>
+                    </a:solidFill>
                   </a:tcPr>
                 </a:tc>
                 <a:tc>
@@ -9187,7 +9378,9 @@
                       <a:headEnd type="none" w="med" len="med"/>
                       <a:tailEnd type="none" w="med" len="med"/>
                     </a:lnB>
-                    <a:noFill/>
+                    <a:solidFill>
+                      <a:srgbClr val="FFFFFF"/>
+                    </a:solidFill>
                   </a:tcPr>
                 </a:tc>
                 <a:tc>
@@ -9226,7 +9419,9 @@
                       <a:headEnd type="none" w="med" len="med"/>
                       <a:tailEnd type="none" w="med" len="med"/>
                     </a:lnB>
-                    <a:noFill/>
+                    <a:solidFill>
+                      <a:srgbClr val="FFFFFF"/>
+                    </a:solidFill>
                   </a:tcPr>
                 </a:tc>
                 <a:tc>
@@ -9265,7 +9460,9 @@
                       <a:headEnd type="none" w="med" len="med"/>
                       <a:tailEnd type="none" w="med" len="med"/>
                     </a:lnB>
-                    <a:noFill/>
+                    <a:solidFill>
+                      <a:srgbClr val="FFFFFF"/>
+                    </a:solidFill>
                   </a:tcPr>
                 </a:tc>
                 <a:tc>
@@ -9304,7 +9501,9 @@
                       <a:headEnd type="none" w="med" len="med"/>
                       <a:tailEnd type="none" w="med" len="med"/>
                     </a:lnB>
-                    <a:noFill/>
+                    <a:solidFill>
+                      <a:srgbClr val="FFFFFF"/>
+                    </a:solidFill>
                   </a:tcPr>
                 </a:tc>
                 <a:tc>
@@ -9343,7 +9542,9 @@
                       <a:headEnd type="none" w="med" len="med"/>
                       <a:tailEnd type="none" w="med" len="med"/>
                     </a:lnB>
-                    <a:noFill/>
+                    <a:solidFill>
+                      <a:srgbClr val="FFFFFF"/>
+                    </a:solidFill>
                   </a:tcPr>
                 </a:tc>
               </a:tr>
@@ -9390,7 +9591,9 @@
                       <a:headEnd type="none" w="med" len="med"/>
                       <a:tailEnd type="none" w="med" len="med"/>
                     </a:lnB>
-                    <a:noFill/>
+                    <a:solidFill>
+                      <a:srgbClr val="FFFFFF"/>
+                    </a:solidFill>
                   </a:tcPr>
                 </a:tc>
                 <a:tc>
@@ -9435,7 +9638,9 @@
                       <a:headEnd type="none" w="med" len="med"/>
                       <a:tailEnd type="none" w="med" len="med"/>
                     </a:lnB>
-                    <a:noFill/>
+                    <a:solidFill>
+                      <a:srgbClr val="FFFFFF"/>
+                    </a:solidFill>
                   </a:tcPr>
                 </a:tc>
                 <a:tc>
@@ -9480,7 +9685,9 @@
                       <a:headEnd type="none" w="med" len="med"/>
                       <a:tailEnd type="none" w="med" len="med"/>
                     </a:lnB>
-                    <a:noFill/>
+                    <a:solidFill>
+                      <a:srgbClr val="FFFFFF"/>
+                    </a:solidFill>
                   </a:tcPr>
                 </a:tc>
                 <a:tc>
@@ -9525,7 +9732,9 @@
                       <a:headEnd type="none" w="med" len="med"/>
                       <a:tailEnd type="none" w="med" len="med"/>
                     </a:lnB>
-                    <a:noFill/>
+                    <a:solidFill>
+                      <a:srgbClr val="FFFFFF"/>
+                    </a:solidFill>
                   </a:tcPr>
                 </a:tc>
                 <a:tc>
@@ -9570,7 +9779,9 @@
                       <a:headEnd type="none" w="med" len="med"/>
                       <a:tailEnd type="none" w="med" len="med"/>
                     </a:lnB>
-                    <a:noFill/>
+                    <a:solidFill>
+                      <a:srgbClr val="FFFFFF"/>
+                    </a:solidFill>
                   </a:tcPr>
                 </a:tc>
                 <a:tc>
@@ -9615,7 +9826,9 @@
                       <a:headEnd type="none" w="med" len="med"/>
                       <a:tailEnd type="none" w="med" len="med"/>
                     </a:lnB>
-                    <a:noFill/>
+                    <a:solidFill>
+                      <a:srgbClr val="FFFFFF"/>
+                    </a:solidFill>
                   </a:tcPr>
                 </a:tc>
                 <a:tc>
@@ -9660,7 +9873,9 @@
                       <a:headEnd type="none" w="med" len="med"/>
                       <a:tailEnd type="none" w="med" len="med"/>
                     </a:lnB>
-                    <a:noFill/>
+                    <a:solidFill>
+                      <a:srgbClr val="FFFFFF"/>
+                    </a:solidFill>
                   </a:tcPr>
                 </a:tc>
               </a:tr>
@@ -9707,7 +9922,9 @@
                       <a:headEnd type="none" w="med" len="med"/>
                       <a:tailEnd type="none" w="med" len="med"/>
                     </a:lnB>
-                    <a:noFill/>
+                    <a:solidFill>
+                      <a:srgbClr val="FFFFFF"/>
+                    </a:solidFill>
                   </a:tcPr>
                 </a:tc>
                 <a:tc>
@@ -9752,7 +9969,9 @@
                       <a:headEnd type="none" w="med" len="med"/>
                       <a:tailEnd type="none" w="med" len="med"/>
                     </a:lnB>
-                    <a:noFill/>
+                    <a:solidFill>
+                      <a:srgbClr val="FFFFFF"/>
+                    </a:solidFill>
                   </a:tcPr>
                 </a:tc>
                 <a:tc>
@@ -9797,7 +10016,9 @@
                       <a:headEnd type="none" w="med" len="med"/>
                       <a:tailEnd type="none" w="med" len="med"/>
                     </a:lnB>
-                    <a:noFill/>
+                    <a:solidFill>
+                      <a:srgbClr val="FFFFFF"/>
+                    </a:solidFill>
                   </a:tcPr>
                 </a:tc>
                 <a:tc>
@@ -9842,7 +10063,9 @@
                       <a:headEnd type="none" w="med" len="med"/>
                       <a:tailEnd type="none" w="med" len="med"/>
                     </a:lnB>
-                    <a:noFill/>
+                    <a:solidFill>
+                      <a:srgbClr val="FFFFFF"/>
+                    </a:solidFill>
                   </a:tcPr>
                 </a:tc>
                 <a:tc>
@@ -9887,7 +10110,9 @@
                       <a:headEnd type="none" w="med" len="med"/>
                       <a:tailEnd type="none" w="med" len="med"/>
                     </a:lnB>
-                    <a:noFill/>
+                    <a:solidFill>
+                      <a:srgbClr val="FFFFFF"/>
+                    </a:solidFill>
                   </a:tcPr>
                 </a:tc>
                 <a:tc>
@@ -9932,7 +10157,9 @@
                       <a:headEnd type="none" w="med" len="med"/>
                       <a:tailEnd type="none" w="med" len="med"/>
                     </a:lnB>
-                    <a:noFill/>
+                    <a:solidFill>
+                      <a:srgbClr val="FFFFFF"/>
+                    </a:solidFill>
                   </a:tcPr>
                 </a:tc>
                 <a:tc>
@@ -9977,7 +10204,9 @@
                       <a:headEnd type="none" w="med" len="med"/>
                       <a:tailEnd type="none" w="med" len="med"/>
                     </a:lnB>
-                    <a:noFill/>
+                    <a:solidFill>
+                      <a:srgbClr val="FFFFFF"/>
+                    </a:solidFill>
                   </a:tcPr>
                 </a:tc>
               </a:tr>
@@ -10024,7 +10253,9 @@
                       <a:headEnd type="none" w="med" len="med"/>
                       <a:tailEnd type="none" w="med" len="med"/>
                     </a:lnB>
-                    <a:noFill/>
+                    <a:solidFill>
+                      <a:srgbClr val="FFFFFF"/>
+                    </a:solidFill>
                   </a:tcPr>
                 </a:tc>
                 <a:tc>
@@ -10069,7 +10300,9 @@
                       <a:headEnd type="none" w="med" len="med"/>
                       <a:tailEnd type="none" w="med" len="med"/>
                     </a:lnB>
-                    <a:noFill/>
+                    <a:solidFill>
+                      <a:srgbClr val="FFFFFF"/>
+                    </a:solidFill>
                   </a:tcPr>
                 </a:tc>
                 <a:tc>
@@ -10114,7 +10347,9 @@
                       <a:headEnd type="none" w="med" len="med"/>
                       <a:tailEnd type="none" w="med" len="med"/>
                     </a:lnB>
-                    <a:noFill/>
+                    <a:solidFill>
+                      <a:srgbClr val="FFFFFF"/>
+                    </a:solidFill>
                   </a:tcPr>
                 </a:tc>
                 <a:tc>
@@ -10159,7 +10394,9 @@
                       <a:headEnd type="none" w="med" len="med"/>
                       <a:tailEnd type="none" w="med" len="med"/>
                     </a:lnB>
-                    <a:noFill/>
+                    <a:solidFill>
+                      <a:srgbClr val="FFFFFF"/>
+                    </a:solidFill>
                   </a:tcPr>
                 </a:tc>
                 <a:tc>
@@ -10204,7 +10441,9 @@
                       <a:headEnd type="none" w="med" len="med"/>
                       <a:tailEnd type="none" w="med" len="med"/>
                     </a:lnB>
-                    <a:noFill/>
+                    <a:solidFill>
+                      <a:srgbClr val="FFFFFF"/>
+                    </a:solidFill>
                   </a:tcPr>
                 </a:tc>
                 <a:tc>
@@ -10249,7 +10488,9 @@
                       <a:headEnd type="none" w="med" len="med"/>
                       <a:tailEnd type="none" w="med" len="med"/>
                     </a:lnB>
-                    <a:noFill/>
+                    <a:solidFill>
+                      <a:srgbClr val="FFFFFF"/>
+                    </a:solidFill>
                   </a:tcPr>
                 </a:tc>
                 <a:tc>
@@ -10294,7 +10535,9 @@
                       <a:headEnd type="none" w="med" len="med"/>
                       <a:tailEnd type="none" w="med" len="med"/>
                     </a:lnB>
-                    <a:noFill/>
+                    <a:solidFill>
+                      <a:srgbClr val="FFFFFF"/>
+                    </a:solidFill>
                   </a:tcPr>
                 </a:tc>
               </a:tr>
@@ -10341,7 +10584,9 @@
                       <a:headEnd type="none" w="med" len="med"/>
                       <a:tailEnd type="none" w="med" len="med"/>
                     </a:lnB>
-                    <a:noFill/>
+                    <a:solidFill>
+                      <a:srgbClr val="FFFFFF"/>
+                    </a:solidFill>
                   </a:tcPr>
                 </a:tc>
                 <a:tc>
@@ -10386,7 +10631,9 @@
                       <a:headEnd type="none" w="med" len="med"/>
                       <a:tailEnd type="none" w="med" len="med"/>
                     </a:lnB>
-                    <a:noFill/>
+                    <a:solidFill>
+                      <a:srgbClr val="FFFFFF"/>
+                    </a:solidFill>
                   </a:tcPr>
                 </a:tc>
                 <a:tc>
@@ -10431,7 +10678,9 @@
                       <a:headEnd type="none" w="med" len="med"/>
                       <a:tailEnd type="none" w="med" len="med"/>
                     </a:lnB>
-                    <a:noFill/>
+                    <a:solidFill>
+                      <a:srgbClr val="FFFFFF"/>
+                    </a:solidFill>
                   </a:tcPr>
                 </a:tc>
                 <a:tc>
@@ -10476,7 +10725,9 @@
                       <a:headEnd type="none" w="med" len="med"/>
                       <a:tailEnd type="none" w="med" len="med"/>
                     </a:lnB>
-                    <a:noFill/>
+                    <a:solidFill>
+                      <a:srgbClr val="FFFFFF"/>
+                    </a:solidFill>
                   </a:tcPr>
                 </a:tc>
                 <a:tc>
@@ -10521,7 +10772,9 @@
                       <a:headEnd type="none" w="med" len="med"/>
                       <a:tailEnd type="none" w="med" len="med"/>
                     </a:lnB>
-                    <a:noFill/>
+                    <a:solidFill>
+                      <a:srgbClr val="FFFFFF"/>
+                    </a:solidFill>
                   </a:tcPr>
                 </a:tc>
                 <a:tc>
@@ -10566,7 +10819,9 @@
                       <a:headEnd type="none" w="med" len="med"/>
                       <a:tailEnd type="none" w="med" len="med"/>
                     </a:lnB>
-                    <a:noFill/>
+                    <a:solidFill>
+                      <a:srgbClr val="FFFFFF"/>
+                    </a:solidFill>
                   </a:tcPr>
                 </a:tc>
                 <a:tc>
@@ -10611,7 +10866,9 @@
                       <a:headEnd type="none" w="med" len="med"/>
                       <a:tailEnd type="none" w="med" len="med"/>
                     </a:lnB>
-                    <a:noFill/>
+                    <a:solidFill>
+                      <a:srgbClr val="FFFFFF"/>
+                    </a:solidFill>
                   </a:tcPr>
                 </a:tc>
               </a:tr>
@@ -10658,7 +10915,9 @@
                       <a:headEnd type="none" w="med" len="med"/>
                       <a:tailEnd type="none" w="med" len="med"/>
                     </a:lnB>
-                    <a:noFill/>
+                    <a:solidFill>
+                      <a:srgbClr val="FFFFFF"/>
+                    </a:solidFill>
                   </a:tcPr>
                 </a:tc>
                 <a:tc>
@@ -10703,7 +10962,9 @@
                       <a:headEnd type="none" w="med" len="med"/>
                       <a:tailEnd type="none" w="med" len="med"/>
                     </a:lnB>
-                    <a:noFill/>
+                    <a:solidFill>
+                      <a:srgbClr val="FFFFFF"/>
+                    </a:solidFill>
                   </a:tcPr>
                 </a:tc>
                 <a:tc>
@@ -10748,7 +11009,9 @@
                       <a:headEnd type="none" w="med" len="med"/>
                       <a:tailEnd type="none" w="med" len="med"/>
                     </a:lnB>
-                    <a:noFill/>
+                    <a:solidFill>
+                      <a:srgbClr val="FFFFFF"/>
+                    </a:solidFill>
                   </a:tcPr>
                 </a:tc>
                 <a:tc>
@@ -10793,7 +11056,9 @@
                       <a:headEnd type="none" w="med" len="med"/>
                       <a:tailEnd type="none" w="med" len="med"/>
                     </a:lnB>
-                    <a:noFill/>
+                    <a:solidFill>
+                      <a:srgbClr val="FFFFFF"/>
+                    </a:solidFill>
                   </a:tcPr>
                 </a:tc>
                 <a:tc>
@@ -10838,7 +11103,9 @@
                       <a:headEnd type="none" w="med" len="med"/>
                       <a:tailEnd type="none" w="med" len="med"/>
                     </a:lnB>
-                    <a:noFill/>
+                    <a:solidFill>
+                      <a:srgbClr val="FFFFFF"/>
+                    </a:solidFill>
                   </a:tcPr>
                 </a:tc>
                 <a:tc>
@@ -10883,7 +11150,9 @@
                       <a:headEnd type="none" w="med" len="med"/>
                       <a:tailEnd type="none" w="med" len="med"/>
                     </a:lnB>
-                    <a:noFill/>
+                    <a:solidFill>
+                      <a:srgbClr val="FFFFFF"/>
+                    </a:solidFill>
                   </a:tcPr>
                 </a:tc>
                 <a:tc>
@@ -10928,7 +11197,9 @@
                       <a:headEnd type="none" w="med" len="med"/>
                       <a:tailEnd type="none" w="med" len="med"/>
                     </a:lnB>
-                    <a:noFill/>
+                    <a:solidFill>
+                      <a:srgbClr val="FFFFFF"/>
+                    </a:solidFill>
                   </a:tcPr>
                 </a:tc>
               </a:tr>
@@ -10997,7 +11268,7 @@
             <a:r>
               <a:rPr sz="1600" b="0">
                 <a:solidFill>
-                  <a:srgbClr val="616E7C"/>
+                  <a:srgbClr val="55606E"/>
                 </a:solidFill>
                 <a:latin typeface="Calibri"/>
               </a:rPr>
@@ -11031,7 +11302,7 @@
             <a:r>
               <a:rPr sz="1000" b="0">
                 <a:solidFill>
-                  <a:srgbClr val="616E7C"/>
+                  <a:srgbClr val="55606E"/>
                 </a:solidFill>
                 <a:latin typeface="Calibri"/>
               </a:rPr>
@@ -11066,7 +11337,7 @@
             <a:r>
               <a:rPr sz="1000" b="0">
                 <a:solidFill>
-                  <a:srgbClr val="616E7C"/>
+                  <a:srgbClr val="55606E"/>
                 </a:solidFill>
                 <a:latin typeface="Calibri"/>
               </a:rPr>
@@ -11100,7 +11371,7 @@
             <a:r>
               <a:rPr sz="1400" b="0">
                 <a:solidFill>
-                  <a:srgbClr val="616E7C"/>
+                  <a:srgbClr val="55606E"/>
                 </a:solidFill>
                 <a:latin typeface="Calibri"/>
               </a:rPr>
@@ -11381,6 +11652,14 @@
 <file path=ppt/slides/slide7.xml><?xml version="1.0" encoding="utf-8"?>
 <p:sld xmlns:a="http://schemas.openxmlformats.org/drawingml/2006/main" xmlns:p="http://schemas.openxmlformats.org/presentationml/2006/main" xmlns:r="http://schemas.openxmlformats.org/officeDocument/2006/relationships">
   <p:cSld>
+    <p:bg>
+      <p:bgPr>
+        <a:solidFill>
+          <a:srgbClr val="E4EFEC"/>
+        </a:solidFill>
+        <a:effectLst/>
+      </p:bgPr>
+    </p:bg>
     <p:spTree>
       <p:nvGrpSpPr>
         <p:cNvPr id="1" name=""/>
@@ -11502,7 +11781,7 @@
             <a:r>
               <a:rPr sz="1600" b="0">
                 <a:solidFill>
-                  <a:srgbClr val="616E7C"/>
+                  <a:srgbClr val="55606E"/>
                 </a:solidFill>
                 <a:latin typeface="Calibri"/>
               </a:rPr>
@@ -11536,7 +11815,7 @@
             <a:r>
               <a:rPr sz="1000" b="0">
                 <a:solidFill>
-                  <a:srgbClr val="616E7C"/>
+                  <a:srgbClr val="55606E"/>
                 </a:solidFill>
                 <a:latin typeface="Calibri"/>
               </a:rPr>
@@ -11571,7 +11850,7 @@
             <a:r>
               <a:rPr sz="1000" b="0">
                 <a:solidFill>
-                  <a:srgbClr val="616E7C"/>
+                  <a:srgbClr val="55606E"/>
                 </a:solidFill>
                 <a:latin typeface="Calibri"/>
               </a:rPr>
@@ -11595,7 +11874,7 @@
             <a:avLst/>
           </a:prstGeom>
           <a:solidFill>
-            <a:srgbClr val="F2F5F5"/>
+            <a:srgbClr val="FFFFFF"/>
           </a:solidFill>
           <a:ln>
             <a:noFill/>
@@ -12118,6 +12397,14 @@
 <file path=ppt/slides/slide8.xml><?xml version="1.0" encoding="utf-8"?>
 <p:sld xmlns:a="http://schemas.openxmlformats.org/drawingml/2006/main" xmlns:p="http://schemas.openxmlformats.org/presentationml/2006/main" xmlns:r="http://schemas.openxmlformats.org/officeDocument/2006/relationships">
   <p:cSld>
+    <p:bg>
+      <p:bgPr>
+        <a:solidFill>
+          <a:srgbClr val="E4EFEC"/>
+        </a:solidFill>
+        <a:effectLst/>
+      </p:bgPr>
+    </p:bg>
     <p:spTree>
       <p:nvGrpSpPr>
         <p:cNvPr id="1" name=""/>
@@ -12173,7 +12460,7 @@
             <a:avLst/>
           </a:prstGeom>
           <a:solidFill>
-            <a:srgbClr val="F2F5F5"/>
+            <a:srgbClr val="FFFFFF"/>
           </a:solidFill>
           <a:ln>
             <a:noFill/>
@@ -12466,7 +12753,7 @@
             <a:r>
               <a:rPr sz="1600" b="0">
                 <a:solidFill>
-                  <a:srgbClr val="616E7C"/>
+                  <a:srgbClr val="55606E"/>
                 </a:solidFill>
                 <a:latin typeface="Calibri"/>
               </a:rPr>
@@ -12500,7 +12787,7 @@
             <a:r>
               <a:rPr sz="1000" b="0">
                 <a:solidFill>
-                  <a:srgbClr val="616E7C"/>
+                  <a:srgbClr val="55606E"/>
                 </a:solidFill>
                 <a:latin typeface="Calibri"/>
               </a:rPr>
@@ -12535,7 +12822,7 @@
             <a:r>
               <a:rPr sz="1000" b="0">
                 <a:solidFill>
-                  <a:srgbClr val="616E7C"/>
+                  <a:srgbClr val="55606E"/>
                 </a:solidFill>
                 <a:latin typeface="Calibri"/>
               </a:rPr>
@@ -12844,6 +13131,14 @@
 <file path=ppt/slides/slide9.xml><?xml version="1.0" encoding="utf-8"?>
 <p:sld xmlns:a="http://schemas.openxmlformats.org/drawingml/2006/main" xmlns:p="http://schemas.openxmlformats.org/presentationml/2006/main" xmlns:r="http://schemas.openxmlformats.org/officeDocument/2006/relationships">
   <p:cSld>
+    <p:bg>
+      <p:bgPr>
+        <a:solidFill>
+          <a:srgbClr val="0F766E"/>
+        </a:solidFill>
+        <a:effectLst/>
+      </p:bgPr>
+    </p:bg>
     <p:spTree>
       <p:nvGrpSpPr>
         <p:cNvPr id="1" name=""/>
@@ -12853,106 +13148,20 @@
       <p:grpSpPr/>
       <p:sp>
         <p:nvSpPr>
-          <p:cNvPr id="2" name="Title 1"/>
-          <p:cNvSpPr>
-            <a:spLocks noGrp="1"/>
-          </p:cNvSpPr>
-          <p:nvPr>
-            <p:ph type="ctrTitle"/>
-          </p:nvPr>
+          <p:cNvPr id="4" name="Oval 3"/>
+          <p:cNvSpPr/>
+          <p:nvPr/>
         </p:nvSpPr>
         <p:spPr>
           <a:xfrm>
-            <a:off x="1005840" y="2057400"/>
-            <a:ext cx="10180320" cy="1371600"/>
+            <a:off x="7985760" y="-1645920"/>
+            <a:ext cx="6583680" cy="6583680"/>
           </a:xfrm>
-        </p:spPr>
-        <p:txBody>
-          <a:bodyPr anchor="b"/>
-          <a:lstStyle/>
-          <a:p>
-            <a:pPr algn="l"/>
-            <a:r>
-              <a:rPr sz="4800" b="0">
-                <a:solidFill>
-                  <a:srgbClr val="1F2933"/>
-                </a:solidFill>
-                <a:latin typeface="Calibri Light"/>
-              </a:rPr>
-              <a:t>Thank You</a:t>
-            </a:r>
-          </a:p>
-        </p:txBody>
-      </p:sp>
-      <p:sp>
-        <p:nvSpPr>
-          <p:cNvPr id="3" name="Subtitle 2"/>
-          <p:cNvSpPr>
-            <a:spLocks noGrp="1"/>
-          </p:cNvSpPr>
-          <p:nvPr>
-            <p:ph type="subTitle" idx="1"/>
-          </p:nvPr>
-        </p:nvSpPr>
-        <p:spPr>
-          <a:xfrm>
-            <a:off x="1005840" y="3840480"/>
-            <a:ext cx="10180320" cy="1828800"/>
-          </a:xfrm>
-        </p:spPr>
-        <p:txBody>
-          <a:bodyPr anchor="t"/>
-          <a:lstStyle/>
-          <a:p>
-            <a:pPr algn="l">
-              <a:spcAft>
-                <a:spcPts val="800"/>
-              </a:spcAft>
-            </a:pPr>
-            <a:r>
-              <a:rPr sz="2400" b="0">
-                <a:solidFill>
-                  <a:srgbClr val="616E7C"/>
-                </a:solidFill>
-                <a:latin typeface="Calibri"/>
-              </a:rPr>
-              <a:t>Any questions?</a:t>
-            </a:r>
-          </a:p>
-          <a:p>
-            <a:pPr algn="l">
-              <a:spcAft>
-                <a:spcPts val="800"/>
-              </a:spcAft>
-            </a:pPr>
-            <a:r>
-              <a:rPr sz="1600" b="0">
-                <a:solidFill>
-                  <a:srgbClr val="616E7C"/>
-                </a:solidFill>
-                <a:latin typeface="Calibri"/>
-              </a:rPr>
-              <a:t>SkillUp Academy  ·  Market Research Lab</a:t>
-            </a:r>
-          </a:p>
-        </p:txBody>
-      </p:sp>
-      <p:sp>
-        <p:nvSpPr>
-          <p:cNvPr id="4" name="Rectangle 3"/>
-          <p:cNvSpPr/>
-          <p:nvPr/>
-        </p:nvSpPr>
-        <p:spPr>
-          <a:xfrm>
-            <a:off x="0" y="0"/>
-            <a:ext cx="256032" cy="6858000"/>
-          </a:xfrm>
-          <a:prstGeom prst="rect">
+          <a:prstGeom prst="ellipse">
             <a:avLst/>
           </a:prstGeom>
           <a:solidFill>
-            <a:srgbClr val="0F766E"/>
+            <a:srgbClr val="13827A"/>
           </a:solidFill>
           <a:ln>
             <a:noFill/>
@@ -12980,9 +13189,138 @@
           </a:p>
         </p:txBody>
       </p:sp>
+      <p:sp>
+        <p:nvSpPr>
+          <p:cNvPr id="5" name="Oval 4"/>
+          <p:cNvSpPr/>
+          <p:nvPr/>
+        </p:nvSpPr>
+        <p:spPr>
+          <a:xfrm>
+            <a:off x="9448800" y="3840480"/>
+            <a:ext cx="4114800" cy="4114800"/>
+          </a:xfrm>
+          <a:prstGeom prst="ellipse">
+            <a:avLst/>
+          </a:prstGeom>
+          <a:noFill/>
+          <a:ln w="15875">
+            <a:solidFill>
+              <a:srgbClr val="8ED1C7"/>
+            </a:solidFill>
+          </a:ln>
+        </p:spPr>
+        <p:style>
+          <a:lnRef idx="1">
+            <a:schemeClr val="accent1"/>
+          </a:lnRef>
+          <a:fillRef idx="3">
+            <a:schemeClr val="accent1"/>
+          </a:fillRef>
+          <a:effectRef idx="2">
+            <a:schemeClr val="accent1"/>
+          </a:effectRef>
+          <a:fontRef idx="minor">
+            <a:schemeClr val="lt1"/>
+          </a:fontRef>
+        </p:style>
+        <p:txBody>
+          <a:bodyPr rtlCol="0" anchor="ctr"/>
+          <a:lstStyle/>
+          <a:p>
+            <a:pPr algn="ctr"/>
+          </a:p>
+        </p:txBody>
+      </p:sp>
+      <p:sp>
+        <p:nvSpPr>
+          <p:cNvPr id="2" name="Title 1"/>
+          <p:cNvSpPr>
+            <a:spLocks noGrp="1"/>
+          </p:cNvSpPr>
+          <p:nvPr>
+            <p:ph type="ctrTitle"/>
+          </p:nvPr>
+        </p:nvSpPr>
+        <p:spPr>
+          <a:xfrm>
+            <a:off x="1005840" y="2057400"/>
+            <a:ext cx="10180320" cy="1371600"/>
+          </a:xfrm>
+        </p:spPr>
+        <p:txBody>
+          <a:bodyPr anchor="b"/>
+          <a:lstStyle/>
+          <a:p>
+            <a:pPr algn="l"/>
+            <a:r>
+              <a:rPr sz="4800" b="0">
+                <a:solidFill>
+                  <a:srgbClr val="FFFFFF"/>
+                </a:solidFill>
+                <a:latin typeface="Calibri Light"/>
+              </a:rPr>
+              <a:t>Thank You</a:t>
+            </a:r>
+          </a:p>
+        </p:txBody>
+      </p:sp>
+      <p:sp>
+        <p:nvSpPr>
+          <p:cNvPr id="3" name="Subtitle 2"/>
+          <p:cNvSpPr>
+            <a:spLocks noGrp="1"/>
+          </p:cNvSpPr>
+          <p:nvPr>
+            <p:ph type="subTitle" idx="1"/>
+          </p:nvPr>
+        </p:nvSpPr>
+        <p:spPr>
+          <a:xfrm>
+            <a:off x="1005840" y="3840480"/>
+            <a:ext cx="10180320" cy="1828800"/>
+          </a:xfrm>
+        </p:spPr>
+        <p:txBody>
+          <a:bodyPr anchor="t"/>
+          <a:lstStyle/>
+          <a:p>
+            <a:pPr algn="l">
+              <a:spcAft>
+                <a:spcPts val="800"/>
+              </a:spcAft>
+            </a:pPr>
+            <a:r>
+              <a:rPr sz="2400" b="0">
+                <a:solidFill>
+                  <a:srgbClr val="D3EBE7"/>
+                </a:solidFill>
+                <a:latin typeface="Calibri"/>
+              </a:rPr>
+              <a:t>Any questions?</a:t>
+            </a:r>
+          </a:p>
+          <a:p>
+            <a:pPr algn="l">
+              <a:spcAft>
+                <a:spcPts val="800"/>
+              </a:spcAft>
+            </a:pPr>
+            <a:r>
+              <a:rPr sz="1600" b="0">
+                <a:solidFill>
+                  <a:srgbClr val="D3EBE7"/>
+                </a:solidFill>
+                <a:latin typeface="Calibri"/>
+              </a:rPr>
+              <a:t>SkillUp Academy  ·  Market Research Lab</a:t>
+            </a:r>
+          </a:p>
+        </p:txBody>
+      </p:sp>
       <p:cxnSp>
         <p:nvCxnSpPr>
-          <p:cNvPr id="5" name="Straight Connector 4"/>
+          <p:cNvPr id="6" name="Straight Connector 5"/>
           <p:cNvCxnSpPr/>
           <p:nvPr/>
         </p:nvCxnSpPr>
@@ -12996,7 +13334,7 @@
           </a:prstGeom>
           <a:ln w="38100">
             <a:solidFill>
-              <a:srgbClr val="0F766E"/>
+              <a:srgbClr val="8ED1C7"/>
             </a:solidFill>
           </a:ln>
         </p:spPr>
@@ -13104,7 +13442,7 @@
                                           </p:stCondLst>
                                         </p:cTn>
                                         <p:tgtEl>
-                                          <p:spTgt spid="5"/>
+                                          <p:spTgt spid="6"/>
                                         </p:tgtEl>
                                         <p:attrNameLst>
                                           <p:attrName>style.visibility</p:attrName>
@@ -13118,7 +13456,7 @@
                                       <p:cBhvr>
                                         <p:cTn id="11" dur="500"/>
                                         <p:tgtEl>
-                                          <p:spTgt spid="5"/>
+                                          <p:spTgt spid="6"/>
                                         </p:tgtEl>
                                       </p:cBhvr>
                                     </p:animEffect>

</xml_diff>